<commit_message>
fix: resolve Israel slide layout overlaps
</commit_message>
<xml_diff>
--- a/exports/pptx/starozytny-izrael.pptx
+++ b/exports/pptx/starozytny-izrael.pptx
@@ -6115,8 +6115,8 @@
         </p:nvSpPr>
         <p:spPr>
           <a:xfrm>
-            <a:off x="5895975" y="5590282"/>
-            <a:ext cx="5581649" cy="620018"/>
+            <a:off x="6848475" y="2571750"/>
+            <a:ext cx="4629149" cy="833438"/>
           </a:xfrm>
           <a:prstGeom prst="rect">
             <a:avLst/>
@@ -6148,7 +6148,7 @@
         <p:spPr>
           <a:xfrm>
             <a:off x="733425" y="1604963"/>
-            <a:ext cx="10188773" cy="4381500"/>
+            <a:ext cx="10188773" cy="3810000"/>
           </a:xfrm>
           <a:prstGeom prst="rect">
             <a:avLst/>
@@ -6204,26 +6204,26 @@
         </p:nvSpPr>
         <p:spPr>
           <a:xfrm>
-            <a:off x="6200775" y="5743063"/>
-            <a:ext cx="1035177" cy="348424"/>
-          </a:xfrm>
-          <a:prstGeom prst="rect">
-            <a:avLst/>
-          </a:prstGeom>
-          <a:noFill/>
-          <a:ln/>
-        </p:spPr>
-        <p:txBody>
-          <a:bodyPr wrap="square" lIns="0" tIns="0" rIns="0" bIns="0" rtlCol="0" anchor="ctr">
-            <a:normAutofit/>
-          </a:bodyPr>
-          <a:lstStyle/>
-          <a:p>
-            <a:pPr algn="l" indent="0" marL="0">
-              <a:buNone/>
-            </a:pPr>
-            <a:r>
-              <a:rPr lang="en-US" sz="2025" dirty="0">
+            <a:off x="7153275" y="2715006"/>
+            <a:ext cx="892302" cy="292227"/>
+          </a:xfrm>
+          <a:prstGeom prst="rect">
+            <a:avLst/>
+          </a:prstGeom>
+          <a:noFill/>
+          <a:ln/>
+        </p:spPr>
+        <p:txBody>
+          <a:bodyPr wrap="square" lIns="0" tIns="0" rIns="0" bIns="0" rtlCol="0" anchor="ctr">
+            <a:normAutofit/>
+          </a:bodyPr>
+          <a:lstStyle/>
+          <a:p>
+            <a:pPr algn="l" indent="0" marL="0">
+              <a:buNone/>
+            </a:pPr>
+            <a:r>
+              <a:rPr lang="en-US" sz="1725" dirty="0">
                 <a:solidFill>
                   <a:srgbClr val="FFFFFF"/>
                 </a:solidFill>
@@ -6233,7 +6233,7 @@
               </a:rPr>
               <a:t>Znajdź:</a:t>
             </a:r>
-            <a:endParaRPr lang="en-US" sz="2025" dirty="0"/>
+            <a:endParaRPr lang="en-US" sz="1725" dirty="0"/>
           </a:p>
         </p:txBody>
       </p:sp>
@@ -6245,26 +6245,26 @@
         </p:nvSpPr>
         <p:spPr>
           <a:xfrm>
-            <a:off x="7248525" y="5743063"/>
-            <a:ext cx="4073652" cy="348424"/>
-          </a:xfrm>
-          <a:prstGeom prst="rect">
-            <a:avLst/>
-          </a:prstGeom>
-          <a:noFill/>
-          <a:ln/>
-        </p:spPr>
-        <p:txBody>
-          <a:bodyPr wrap="square" lIns="0" tIns="0" rIns="0" bIns="0" rtlCol="0" anchor="ctr">
-            <a:normAutofit/>
-          </a:bodyPr>
-          <a:lstStyle/>
-          <a:p>
-            <a:pPr algn="l" indent="0" marL="0">
-              <a:buNone/>
-            </a:pPr>
-            <a:r>
-              <a:rPr lang="en-US" sz="2025" b="1" dirty="0">
+            <a:off x="8039100" y="2715006"/>
+            <a:ext cx="2159127" cy="292227"/>
+          </a:xfrm>
+          <a:prstGeom prst="rect">
+            <a:avLst/>
+          </a:prstGeom>
+          <a:noFill/>
+          <a:ln/>
+        </p:spPr>
+        <p:txBody>
+          <a:bodyPr wrap="square" lIns="0" tIns="0" rIns="0" bIns="0" rtlCol="0" anchor="ctr">
+            <a:normAutofit/>
+          </a:bodyPr>
+          <a:lstStyle/>
+          <a:p>
+            <a:pPr algn="l" indent="0" marL="0">
+              <a:buNone/>
+            </a:pPr>
+            <a:r>
+              <a:rPr lang="en-US" sz="1725" b="1" dirty="0">
                 <a:solidFill>
                   <a:srgbClr val="92722B"/>
                 </a:solidFill>
@@ -6272,9 +6272,9 @@
                 <a:ea typeface="Aptos" pitchFamily="34" charset="-122"/>
                 <a:cs typeface="Aptos" pitchFamily="34" charset="-120"/>
               </a:rPr>
-              <a:t>Egipt • Kanaan • Jerozolimę</a:t>
-            </a:r>
-            <a:endParaRPr lang="en-US" sz="2025" dirty="0"/>
+              <a:t>Egipt • Kanaan •</a:t>
+            </a:r>
+            <a:endParaRPr lang="en-US" sz="1725" dirty="0"/>
           </a:p>
         </p:txBody>
       </p:sp>
@@ -6286,7 +6286,48 @@
         </p:nvSpPr>
         <p:spPr>
           <a:xfrm>
-            <a:off x="733425" y="6158294"/>
+            <a:off x="7153275" y="2988850"/>
+            <a:ext cx="1378078" cy="292227"/>
+          </a:xfrm>
+          <a:prstGeom prst="rect">
+            <a:avLst/>
+          </a:prstGeom>
+          <a:noFill/>
+          <a:ln/>
+        </p:spPr>
+        <p:txBody>
+          <a:bodyPr wrap="square" lIns="0" tIns="0" rIns="0" bIns="0" rtlCol="0" anchor="ctr">
+            <a:normAutofit/>
+          </a:bodyPr>
+          <a:lstStyle/>
+          <a:p>
+            <a:pPr algn="l" indent="0" marL="0">
+              <a:buNone/>
+            </a:pPr>
+            <a:r>
+              <a:rPr lang="en-US" sz="1725" b="1" dirty="0">
+                <a:solidFill>
+                  <a:srgbClr val="92722B"/>
+                </a:solidFill>
+                <a:latin typeface="Aptos" pitchFamily="34" charset="0"/>
+                <a:ea typeface="Aptos" pitchFamily="34" charset="-122"/>
+                <a:cs typeface="Aptos" pitchFamily="34" charset="-120"/>
+              </a:rPr>
+              <a:t>Jerozolimę</a:t>
+            </a:r>
+            <a:endParaRPr lang="en-US" sz="1725" dirty="0"/>
+          </a:p>
+        </p:txBody>
+      </p:sp>
+      <p:sp>
+        <p:nvSpPr>
+          <p:cNvPr id="10" name="Text 7"/>
+          <p:cNvSpPr/>
+          <p:nvPr/>
+        </p:nvSpPr>
+        <p:spPr>
+          <a:xfrm>
+            <a:off x="733425" y="5586794"/>
             <a:ext cx="10684002" cy="269748"/>
           </a:xfrm>
           <a:prstGeom prst="rect">
@@ -6321,13 +6362,13 @@
       </p:sp>
       <p:sp>
         <p:nvSpPr>
-          <p:cNvPr id="10" name="Text 7"/>
-          <p:cNvSpPr/>
-          <p:nvPr/>
-        </p:nvSpPr>
-        <p:spPr>
-          <a:xfrm>
-            <a:off x="733425" y="6383024"/>
+          <p:cNvPr id="11" name="Text 8"/>
+          <p:cNvSpPr/>
+          <p:nvPr/>
+        </p:nvSpPr>
+        <p:spPr>
+          <a:xfrm>
+            <a:off x="733425" y="5811524"/>
             <a:ext cx="3911727" cy="269748"/>
           </a:xfrm>
           <a:prstGeom prst="rect">

</xml_diff>